<commit_message>
Refine PPT wording around robustness intent
</commit_message>
<xml_diff>
--- a/work-system/deliverables/log-hunter-ai-presentation-2026-03-21-v11-notes.pptx
+++ b/work-system/deliverables/log-hunter-ai-presentation-2026-03-21-v11-notes.pptx
@@ -1350,7 +1350,7 @@
                   <a:srgbClr val="000000"/>
                 </a:solidFill>
               </a:rPr>
-              <a:t>后续我们会继续围绕三个方向推进：第一，继续增强健壮性、性能提升和日志质量分析能力；第二，把日志反哺建议和整改动作更紧密地连接起来，逐步建立更清晰的验证闭环；第三，在更多环境和更多日志类型中复制这套能力，并继续拓展包括 GC 日志在内的更多分析场景。</a:t>
+              <a:t>后续我们会继续围绕三个方向推进：第一，继续提升对系统稳定性问题和性能问题的分析能力，同时持续改进日志质量；第二，把日志反哺建议和整改动作更紧密地连接起来，逐步建立更清晰的验证闭环；第三，在更多环境和更多日志类型中复制这套能力，并继续拓展包括 GC 日志在内的更多分析场景。</a:t>
             </a:r>
             <a:endParaRPr lang="en-US" sz="1400" b="0" i="0" u="none" strike="noStrike">
               <a:solidFill>
@@ -2502,7 +2502,7 @@
                 <a:cs typeface="Noto Sans SC" panose="020B0200000000000000" charset="-122"/>
                 <a:sym typeface="Noto Sans SC" panose="020B0200000000000000" charset="-122"/>
               </a:rPr>
-              <a:t>所以我们做这个项目，不只是为了把日志拉出来看，而是希望建立一套可复用的日志巡检能力，把问题发现、问题分析、优化建议和后续验证串起来，真正服务于健壮性提升、性能优化和日志质量改进。</a:t>
+              <a:t>所以我们做这个项目，不只是为了把日志拉出来看，而是希望建立一套可复用的日志巡检能力，把问题发现、问题分析、优化建议和后续验证串起来，真正去支撑系统健壮性提升、性能优化和日志质量改进。</a:t>
             </a:r>
             <a:endParaRPr lang="en-US" sz="1200" b="0" i="0" u="none" strike="noStrike">
               <a:solidFill>
@@ -3766,7 +3766,7 @@
                 <a:cs typeface="Noto Sans SC" panose="020B0200000000000000" charset="-122"/>
                 <a:sym typeface="Noto Sans SC" panose="020B0200000000000000" charset="-122"/>
               </a:rPr>
-              <a:t>后续我们会继续增强健壮性、性能和日志质量分析能力，同时把建议落地后的验证环节补得更完整。</a:t>
+              <a:t>后续我们会继续增强对系统稳定性和性能问题的分析能力，持续改进日志质量，同时把建议落地后的验证环节补得更完整。</a:t>
             </a:r>
             <a:endParaRPr lang="en-US" sz="1200" b="0" i="0" u="none" strike="noStrike">
               <a:solidFill>

</xml_diff>